<commit_message>
MKT-54, MKT-55: Data sources panel assets, about page, Sanity cleanup, site snapshots
- Add square icon logos for data sources panel (9 SVGs)
- Add about page draft with origin story, convictions, and founders
- Update data sources panel spec (text-left/cluster-right, cloud effect, tooltips)
- Add Sanity snapshot and cleanup scripts (feature 5 removal)
- Archive production Sanity content and stale v1 logos
- Save dev site content snapshots
- Clean up presentation temp files
</commit_message>
<xml_diff>
--- a/sales/presentations/dashbud-general-audience.pptx
+++ b/sales/presentations/dashbud-general-audience.pptx
@@ -3459,8 +3459,8 @@
         </p:nvSpPr>
         <p:spPr>
           <a:xfrm>
-            <a:off x="1143225" y="685800"/>
-            <a:ext cx="4572300" cy="3429000"/>
+            <a:off x="381000" y="685800"/>
+            <a:ext cx="6096000" cy="3429000"/>
           </a:xfrm>
           <a:custGeom>
             <a:avLst/>
@@ -28873,8 +28873,8 @@
         </p:blipFill>
         <p:spPr>
           <a:xfrm>
-            <a:off x="1884848" y="3047859"/>
-            <a:ext cx="602700" cy="602700"/>
+            <a:off x="1958421" y="3126511"/>
+            <a:ext cx="395897" cy="395897"/>
           </a:xfrm>
           <a:prstGeom prst="rect">
             <a:avLst/>
@@ -28897,8 +28897,8 @@
         </p:blipFill>
         <p:spPr>
           <a:xfrm>
-            <a:off x="4855491" y="2113173"/>
-            <a:ext cx="602700" cy="602700"/>
+            <a:off x="4950084" y="2134194"/>
+            <a:ext cx="368150" cy="368150"/>
           </a:xfrm>
           <a:prstGeom prst="rect">
             <a:avLst/>
@@ -28921,8 +28921,8 @@
         </p:blipFill>
         <p:spPr>
           <a:xfrm>
-            <a:off x="8416572" y="2943902"/>
-            <a:ext cx="602700" cy="602700"/>
+            <a:off x="8458615" y="2833199"/>
+            <a:ext cx="391096" cy="391096"/>
           </a:xfrm>
           <a:prstGeom prst="rect">
             <a:avLst/>
@@ -28946,7 +28946,7 @@
         <p:spPr>
           <a:xfrm>
             <a:off x="6915633" y="4756817"/>
-            <a:ext cx="602700" cy="602700"/>
+            <a:ext cx="403762" cy="403762"/>
           </a:xfrm>
           <a:prstGeom prst="rect">
             <a:avLst/>
@@ -28969,8 +28969,8 @@
         </p:blipFill>
         <p:spPr>
           <a:xfrm>
-            <a:off x="2843245" y="4772784"/>
-            <a:ext cx="602700" cy="602700"/>
+            <a:off x="2885287" y="4714086"/>
+            <a:ext cx="446493" cy="446493"/>
           </a:xfrm>
           <a:prstGeom prst="rect">
             <a:avLst/>

</xml_diff>